<commit_message>
feat(ole): 优先读 p:oleObj 内嵌的 p:pic 预览
Office 2010+ 把 OLE 对象的预览图直接写成 p:oleObj 的 p:pic 子元素，
而此前只走旧式的 VML 快照路径（oleObj@spid → v:shape → v:imagedata）。
只有 p:pic 没有 VML 的文件会掉进「OLE 对象」占位框。

现在优先走 p:pic——它是标准的 a:CT_Picture，能连裁剪 / 效果一起拿到，
且不依赖 spid；VML 作为后备。固件补第 3 页专测这条路：刻意不写 spid，
走 VML 那条会直接返回 null，从而验证确实走的是新路径。

Mac 版存的 PICT 预览仍退回占位框——QuickDraw 解码器是另一个格式解码器的
体量，而它只出现在 Office 2011 及更早的 Mac 文件里，性价比不成立。

Co-Authored-By: Claude Opus 5 <noreply@anthropic.com>
</commit_message>
<xml_diff>
--- a/fixtures/sample-ole.pptx
+++ b/fixtures/sample-ole.pptx
@@ -7,6 +7,7 @@
   <p:sldIdLst>
     <p:sldId id="256" r:id="rId2"/>
     <p:sldId id="257" r:id="rId3"/>
+    <p:sldId id="258" r:id="rId4"/>
   </p:sldIdLst>
   <p:sldSz cx="12192000" cy="6858000"/>
   <p:notesSz cx="6858000" cy="9144000"/>
@@ -239,6 +240,102 @@
           <a:graphicData uri="http://schemas.openxmlformats.org/presentationml/2006/ole">
             <p:oleObj spid="_x0000_s1027" name="Worksheet" r:id="rId3" imgW="2971800" imgH="2374900" progId="Excel.Sheet.12">
               <p:embed/>
+            </p:oleObj>
+          </a:graphicData>
+        </a:graphic>
+      </p:graphicFrame>
+    </p:spTree>
+  </p:cSld>
+  <p:clrMapOvr>
+    <a:masterClrMapping/>
+  </p:clrMapOvr>
+</p:sld>
+</file>
+
+<file path=ppt/slides/slide3.xml><?xml version="1.0" encoding="utf-8"?>
+<p:sld xmlns:a="http://schemas.openxmlformats.org/drawingml/2006/main" xmlns:r="http://schemas.openxmlformats.org/officeDocument/2006/relationships" xmlns:p="http://schemas.openxmlformats.org/presentationml/2006/main">
+  <p:cSld>
+    <p:spTree>
+      <p:nvGrpSpPr>
+        <p:cNvPr id="1" name=""/>
+        <p:cNvGrpSpPr/>
+        <p:nvPr/>
+      </p:nvGrpSpPr>
+      <p:grpSpPr>
+        <a:xfrm>
+          <a:off x="0" y="0"/>
+          <a:ext cx="0" cy="0"/>
+          <a:chOff x="0" y="0"/>
+          <a:chExt cx="0" cy="0"/>
+        </a:xfrm>
+      </p:grpSpPr>
+      <p:sp>
+        <p:nvSpPr>
+          <p:cNvPr id="103" name="sp"/>
+          <p:cNvSpPr/>
+          <p:nvPr/>
+        </p:nvSpPr>
+        <p:spPr>
+          <a:xfrm>
+            <a:off x="381000" y="476250"/>
+            <a:ext cx="11430000" cy="571500"/>
+          </a:xfrm>
+          <a:prstGeom prst="rect">
+            <a:avLst/>
+          </a:prstGeom>
+          <a:noFill/>
+        </p:spPr>
+        <p:txBody>
+          <a:bodyPr anchor="ctr"/>
+          <a:lstStyle/>
+          <a:p>
+            <a:r>
+              <a:rPr sz="2200" b="1">
+                <a:solidFill>
+                  <a:schemeClr val="tx2"/>
+                </a:solidFill>
+              </a:rPr>
+              <a:t>OLE + 内嵌 p:pic 预览 → 不依赖 VML</a:t>
+            </a:r>
+          </a:p>
+        </p:txBody>
+      </p:sp>
+      <p:graphicFrame>
+        <p:nvGraphicFramePr>
+          <p:cNvPr id="23" name="Object 23"/>
+          <p:cNvGraphicFramePr/>
+          <p:nvPr/>
+        </p:nvGraphicFramePr>
+        <p:xfrm>
+          <a:off x="1143000" y="1524000"/>
+          <a:ext cx="4381500" cy="2857500"/>
+        </p:xfrm>
+        <a:graphic>
+          <a:graphicData uri="http://schemas.openxmlformats.org/presentationml/2006/ole">
+            <p:oleObj name="Worksheet" r:id="rId3" imgW="2971800" imgH="2374900" progId="Excel.Sheet.12">
+              <p:embed/>
+              <p:pic>
+                <p:nvPicPr>
+                  <p:cNvPr id="123" name="预览"/>
+                  <p:cNvPicPr/>
+                  <p:nvPr/>
+                </p:nvPicPr>
+                <p:blipFill>
+                  <a:blip r:embed="rId4"/>
+                  <a:stretch>
+                    <a:fillRect/>
+                  </a:stretch>
+                </p:blipFill>
+                <p:spPr>
+                  <a:xfrm>
+                    <a:off x="0" y="0"/>
+                    <a:ext cx="4381500" cy="2857500"/>
+                  </a:xfrm>
+                  <a:prstGeom prst="rect">
+                    <a:avLst/>
+                  </a:prstGeom>
+                </p:spPr>
+              </p:pic>
             </p:oleObj>
           </a:graphicData>
         </a:graphic>

</xml_diff>